<commit_message>
Fix footer crowding and card misalignment in the strategy deck
Tables and the go-to-market steps left almost no gap before the
footer band (row heights summed past the footer's y-position on the
implication, comparison and go-to-market slides). The three decision
cards also drifted out of alignment because their target/body text
auto-flowed under titles of different wrapped line counts. Tightened
row heights for footer clearance and gave each decision card a fixed
title band so target and body copy land on the same line across all
three cards. Re-verified via PowerPoint-rendered PNGs before pushing.

Co-Authored-By: Claude Sonnet 5 <noreply@anthropic.com>
</commit_message>
<xml_diff>
--- a/presentation/Mitron_Bank_Credit_Card_Launch_Strategy.pptx
+++ b/presentation/Mitron_Bank_Credit_Card_Launch_Strategy.pptx
@@ -3360,7 +3360,7 @@
         <p:spPr>
           <a:xfrm>
             <a:off x="822960" y="3246120"/>
-            <a:ext cx="10545775" cy="914400"/>
+            <a:ext cx="10545775" cy="822960"/>
           </a:xfrm>
           <a:prstGeom prst="roundRect">
             <a:avLst>
@@ -3407,7 +3407,7 @@
         </p:nvSpPr>
         <p:spPr>
           <a:xfrm>
-            <a:off x="1097280" y="3474720"/>
+            <a:off x="1097280" y="3429000"/>
             <a:ext cx="457200" cy="457200"/>
           </a:xfrm>
           <a:prstGeom prst="ellipse">
@@ -3451,7 +3451,7 @@
         </p:nvSpPr>
         <p:spPr>
           <a:xfrm>
-            <a:off x="1097280" y="3502151"/>
+            <a:off x="1097280" y="3456432"/>
             <a:ext cx="457200" cy="402336"/>
           </a:xfrm>
           <a:prstGeom prst="rect">
@@ -3568,8 +3568,8 @@
         </p:nvSpPr>
         <p:spPr>
           <a:xfrm>
-            <a:off x="822960" y="4361688"/>
-            <a:ext cx="10545775" cy="914400"/>
+            <a:off x="822960" y="4251960"/>
+            <a:ext cx="10545775" cy="822960"/>
           </a:xfrm>
           <a:prstGeom prst="roundRect">
             <a:avLst>
@@ -3616,7 +3616,7 @@
         </p:nvSpPr>
         <p:spPr>
           <a:xfrm>
-            <a:off x="1097280" y="4590288"/>
+            <a:off x="1097280" y="4434840"/>
             <a:ext cx="457200" cy="457200"/>
           </a:xfrm>
           <a:prstGeom prst="ellipse">
@@ -3660,7 +3660,7 @@
         </p:nvSpPr>
         <p:spPr>
           <a:xfrm>
-            <a:off x="1097280" y="4617720"/>
+            <a:off x="1097280" y="4462272"/>
             <a:ext cx="457200" cy="402336"/>
           </a:xfrm>
           <a:prstGeom prst="rect">
@@ -3699,7 +3699,7 @@
         </p:nvSpPr>
         <p:spPr>
           <a:xfrm>
-            <a:off x="1828800" y="4507992"/>
+            <a:off x="1828800" y="4398264"/>
             <a:ext cx="9265615" cy="320040"/>
           </a:xfrm>
           <a:prstGeom prst="rect">
@@ -3738,7 +3738,7 @@
         </p:nvSpPr>
         <p:spPr>
           <a:xfrm>
-            <a:off x="1828800" y="4846320"/>
+            <a:off x="1828800" y="4736592"/>
             <a:ext cx="9265615" cy="365760"/>
           </a:xfrm>
           <a:prstGeom prst="rect">
@@ -3777,8 +3777,8 @@
         </p:nvSpPr>
         <p:spPr>
           <a:xfrm>
-            <a:off x="822960" y="5477256"/>
-            <a:ext cx="10545775" cy="914400"/>
+            <a:off x="822960" y="5257800"/>
+            <a:ext cx="10545775" cy="822960"/>
           </a:xfrm>
           <a:prstGeom prst="roundRect">
             <a:avLst>
@@ -3825,7 +3825,7 @@
         </p:nvSpPr>
         <p:spPr>
           <a:xfrm>
-            <a:off x="1097280" y="5705856"/>
+            <a:off x="1097280" y="5440680"/>
             <a:ext cx="457200" cy="457200"/>
           </a:xfrm>
           <a:prstGeom prst="ellipse">
@@ -3869,7 +3869,7 @@
         </p:nvSpPr>
         <p:spPr>
           <a:xfrm>
-            <a:off x="1097280" y="5733288"/>
+            <a:off x="1097280" y="5468112"/>
             <a:ext cx="457200" cy="402336"/>
           </a:xfrm>
           <a:prstGeom prst="rect">
@@ -3908,7 +3908,7 @@
         </p:nvSpPr>
         <p:spPr>
           <a:xfrm>
-            <a:off x="1828800" y="5623560"/>
+            <a:off x="1828800" y="5404104"/>
             <a:ext cx="9265615" cy="320040"/>
           </a:xfrm>
           <a:prstGeom prst="rect">
@@ -3947,7 +3947,7 @@
         </p:nvSpPr>
         <p:spPr>
           <a:xfrm>
-            <a:off x="1828800" y="5961888"/>
+            <a:off x="1828800" y="5742432"/>
             <a:ext cx="9265615" cy="365760"/>
           </a:xfrm>
           <a:prstGeom prst="rect">
@@ -8655,7 +8655,7 @@
         </p:nvGraphicFramePr>
         <p:xfrm>
           <a:off x="822960" y="3246120"/>
-          <a:ext cx="10545774" cy="3108960"/>
+          <a:ext cx="10545774" cy="2487168"/>
         </p:xfrm>
         <a:graphic>
           <a:graphicData uri="http://schemas.openxmlformats.org/drawingml/2006/table">
@@ -8668,7 +8668,7 @@
                 <a:gridCol w="3585563"/>
                 <a:gridCol w="4218310"/>
               </a:tblGrid>
-              <a:tr h="777240">
+              <a:tr h="621792">
                 <a:tc>
                   <a:txBody>
                     <a:bodyPr wrap="square"/>
@@ -8736,7 +8736,7 @@
                   </a:tcPr>
                 </a:tc>
               </a:tr>
-              <a:tr h="777240">
+              <a:tr h="621792">
                 <a:tc>
                   <a:txBody>
                     <a:bodyPr wrap="square"/>
@@ -8804,7 +8804,7 @@
                   </a:tcPr>
                 </a:tc>
               </a:tr>
-              <a:tr h="777240">
+              <a:tr h="621792">
                 <a:tc>
                   <a:txBody>
                     <a:bodyPr wrap="square"/>
@@ -8872,7 +8872,7 @@
                   </a:tcPr>
                 </a:tc>
               </a:tr>
-              <a:tr h="777240">
+              <a:tr h="621792">
                 <a:tc>
                   <a:txBody>
                     <a:bodyPr wrap="square"/>
@@ -9185,7 +9185,7 @@
         <p:spPr>
           <a:xfrm>
             <a:off x="1097280" y="3502152"/>
-            <a:ext cx="2783738" cy="3081528"/>
+            <a:ext cx="2783738" cy="237744"/>
           </a:xfrm>
           <a:prstGeom prst="rect">
             <a:avLst/>
@@ -9193,21 +9193,18 @@
           <a:noFill/>
         </p:spPr>
         <p:txBody>
-          <a:bodyPr wrap="square" lIns="0" rIns="0" tIns="0" bIns="0">
+          <a:bodyPr wrap="square" anchor="t" lIns="0" rIns="0" tIns="0" bIns="0">
             <a:spAutoFit/>
           </a:bodyPr>
           <a:lstStyle/>
           <a:p>
-            <a:pPr>
-              <a:lnSpc>
-                <a:spcPct val="100000"/>
-              </a:lnSpc>
-              <a:spcAft>
-                <a:spcPts val="1000"/>
-              </a:spcAft>
-            </a:pPr>
-            <a:r>
-              <a:rPr sz="1100" b="1" spc="100">
+            <a:pPr algn="l">
+              <a:lnSpc>
+                <a:spcPct val="115000"/>
+              </a:lnSpc>
+            </a:pPr>
+            <a:r>
+              <a:rPr sz="1100" b="1" i="0" spc="100">
                 <a:solidFill>
                   <a:srgbClr val="7A5A1E"/>
                 </a:solidFill>
@@ -9216,17 +9213,37 @@
               <a:t>01 — MASS MARKET</a:t>
             </a:r>
           </a:p>
-          <a:p>
-            <a:pPr>
+        </p:txBody>
+      </p:sp>
+      <p:sp>
+        <p:nvSpPr>
+          <p:cNvPr id="5" name="TextBox 4"/>
+          <p:cNvSpPr txBox="1"/>
+          <p:nvPr/>
+        </p:nvSpPr>
+        <p:spPr>
+          <a:xfrm>
+            <a:off x="1097280" y="3776472"/>
+            <a:ext cx="2783738" cy="585216"/>
+          </a:xfrm>
+          <a:prstGeom prst="rect">
+            <a:avLst/>
+          </a:prstGeom>
+          <a:noFill/>
+        </p:spPr>
+        <p:txBody>
+          <a:bodyPr wrap="square" anchor="t" lIns="0" rIns="0" tIns="0" bIns="0">
+            <a:spAutoFit/>
+          </a:bodyPr>
+          <a:lstStyle/>
+          <a:p>
+            <a:pPr algn="l">
               <a:lnSpc>
                 <a:spcPct val="115000"/>
               </a:lnSpc>
-              <a:spcAft>
-                <a:spcPts val="800"/>
-              </a:spcAft>
-            </a:pPr>
-            <a:r>
-              <a:rPr sz="1700" b="1">
+            </a:pPr>
+            <a:r>
+              <a:rPr sz="1700" b="1" i="0">
                 <a:solidFill>
                   <a:srgbClr val="0E1F33"/>
                 </a:solidFill>
@@ -9235,17 +9252,37 @@
               <a:t>Mitron Tech &amp; Bills Elevate</a:t>
             </a:r>
           </a:p>
-          <a:p>
-            <a:pPr>
+        </p:txBody>
+      </p:sp>
+      <p:sp>
+        <p:nvSpPr>
+          <p:cNvPr id="6" name="TextBox 5"/>
+          <p:cNvSpPr txBox="1"/>
+          <p:nvPr/>
+        </p:nvSpPr>
+        <p:spPr>
+          <a:xfrm>
+            <a:off x="1097280" y="4489704"/>
+            <a:ext cx="2783738" cy="274320"/>
+          </a:xfrm>
+          <a:prstGeom prst="rect">
+            <a:avLst/>
+          </a:prstGeom>
+          <a:noFill/>
+        </p:spPr>
+        <p:txBody>
+          <a:bodyPr wrap="square" anchor="t" lIns="0" rIns="0" tIns="0" bIns="0">
+            <a:spAutoFit/>
+          </a:bodyPr>
+          <a:lstStyle/>
+          <a:p>
+            <a:pPr algn="l">
               <a:lnSpc>
                 <a:spcPct val="120000"/>
               </a:lnSpc>
-              <a:spcAft>
-                <a:spcPts val="1600"/>
-              </a:spcAft>
-            </a:pPr>
-            <a:r>
-              <a:rPr sz="1300" b="1">
+            </a:pPr>
+            <a:r>
+              <a:rPr sz="1300" b="1" i="0">
                 <a:solidFill>
                   <a:srgbClr val="7A5A1E"/>
                 </a:solidFill>
@@ -9254,17 +9291,37 @@
               <a:t>Salaried IT &amp; metro professionals</a:t>
             </a:r>
           </a:p>
-          <a:p>
-            <a:pPr>
+        </p:txBody>
+      </p:sp>
+      <p:sp>
+        <p:nvSpPr>
+          <p:cNvPr id="7" name="TextBox 6"/>
+          <p:cNvSpPr txBox="1"/>
+          <p:nvPr/>
+        </p:nvSpPr>
+        <p:spPr>
+          <a:xfrm>
+            <a:off x="1097280" y="4910328"/>
+            <a:ext cx="2783738" cy="841247"/>
+          </a:xfrm>
+          <a:prstGeom prst="rect">
+            <a:avLst/>
+          </a:prstGeom>
+          <a:noFill/>
+        </p:spPr>
+        <p:txBody>
+          <a:bodyPr wrap="square" anchor="t" lIns="0" rIns="0" tIns="0" bIns="0">
+            <a:spAutoFit/>
+          </a:bodyPr>
+          <a:lstStyle/>
+          <a:p>
+            <a:pPr algn="l">
               <a:lnSpc>
                 <a:spcPct val="140000"/>
               </a:lnSpc>
-              <a:spcAft>
-                <a:spcPts val="0"/>
-              </a:spcAft>
-            </a:pPr>
-            <a:r>
-              <a:rPr sz="1300" b="0">
+            </a:pPr>
+            <a:r>
+              <a:rPr sz="1300" b="0" i="0">
                 <a:solidFill>
                   <a:srgbClr val="4A5568"/>
                 </a:solidFill>
@@ -9277,7 +9334,7 @@
       </p:sp>
       <p:sp>
         <p:nvSpPr>
-          <p:cNvPr id="5" name="Rounded Rectangle 4"/>
+          <p:cNvPr id="8" name="Rounded Rectangle 7"/>
           <p:cNvSpPr/>
           <p:nvPr/>
         </p:nvSpPr>
@@ -9325,14 +9382,14 @@
       </p:sp>
       <p:sp>
         <p:nvSpPr>
-          <p:cNvPr id="6" name="TextBox 5"/>
+          <p:cNvPr id="9" name="TextBox 8"/>
           <p:cNvSpPr txBox="1"/>
           <p:nvPr/>
         </p:nvSpPr>
         <p:spPr>
           <a:xfrm>
             <a:off x="4703978" y="3502152"/>
-            <a:ext cx="2783738" cy="3081528"/>
+            <a:ext cx="2783738" cy="237744"/>
           </a:xfrm>
           <a:prstGeom prst="rect">
             <a:avLst/>
@@ -9340,21 +9397,18 @@
           <a:noFill/>
         </p:spPr>
         <p:txBody>
-          <a:bodyPr wrap="square" lIns="0" rIns="0" tIns="0" bIns="0">
+          <a:bodyPr wrap="square" anchor="t" lIns="0" rIns="0" tIns="0" bIns="0">
             <a:spAutoFit/>
           </a:bodyPr>
           <a:lstStyle/>
           <a:p>
-            <a:pPr>
-              <a:lnSpc>
-                <a:spcPct val="100000"/>
-              </a:lnSpc>
-              <a:spcAft>
-                <a:spcPts val="1000"/>
-              </a:spcAft>
-            </a:pPr>
-            <a:r>
-              <a:rPr sz="1100" b="1" spc="100">
+            <a:pPr algn="l">
+              <a:lnSpc>
+                <a:spcPct val="115000"/>
+              </a:lnSpc>
+            </a:pPr>
+            <a:r>
+              <a:rPr sz="1100" b="1" i="0" spc="100">
                 <a:solidFill>
                   <a:srgbClr val="7A5A1E"/>
                 </a:solidFill>
@@ -9363,17 +9417,37 @@
               <a:t>02 — MID-TIER VOLUME</a:t>
             </a:r>
           </a:p>
-          <a:p>
-            <a:pPr>
+        </p:txBody>
+      </p:sp>
+      <p:sp>
+        <p:nvSpPr>
+          <p:cNvPr id="10" name="TextBox 9"/>
+          <p:cNvSpPr txBox="1"/>
+          <p:nvPr/>
+        </p:nvSpPr>
+        <p:spPr>
+          <a:xfrm>
+            <a:off x="4703978" y="3776472"/>
+            <a:ext cx="2783738" cy="585216"/>
+          </a:xfrm>
+          <a:prstGeom prst="rect">
+            <a:avLst/>
+          </a:prstGeom>
+          <a:noFill/>
+        </p:spPr>
+        <p:txBody>
+          <a:bodyPr wrap="square" anchor="t" lIns="0" rIns="0" tIns="0" bIns="0">
+            <a:spAutoFit/>
+          </a:bodyPr>
+          <a:lstStyle/>
+          <a:p>
+            <a:pPr algn="l">
               <a:lnSpc>
                 <a:spcPct val="115000"/>
               </a:lnSpc>
-              <a:spcAft>
-                <a:spcPts val="800"/>
-              </a:spcAft>
-            </a:pPr>
-            <a:r>
-              <a:rPr sz="1700" b="1">
+            </a:pPr>
+            <a:r>
+              <a:rPr sz="1700" b="1" i="0">
                 <a:solidFill>
                   <a:srgbClr val="0E1F33"/>
                 </a:solidFill>
@@ -9382,17 +9456,37 @@
               <a:t>Mitron Family &amp; Lifestyle Rewards</a:t>
             </a:r>
           </a:p>
-          <a:p>
-            <a:pPr>
+        </p:txBody>
+      </p:sp>
+      <p:sp>
+        <p:nvSpPr>
+          <p:cNvPr id="11" name="TextBox 10"/>
+          <p:cNvSpPr txBox="1"/>
+          <p:nvPr/>
+        </p:nvSpPr>
+        <p:spPr>
+          <a:xfrm>
+            <a:off x="4703978" y="4489704"/>
+            <a:ext cx="2783738" cy="274320"/>
+          </a:xfrm>
+          <a:prstGeom prst="rect">
+            <a:avLst/>
+          </a:prstGeom>
+          <a:noFill/>
+        </p:spPr>
+        <p:txBody>
+          <a:bodyPr wrap="square" anchor="t" lIns="0" rIns="0" tIns="0" bIns="0">
+            <a:spAutoFit/>
+          </a:bodyPr>
+          <a:lstStyle/>
+          <a:p>
+            <a:pPr algn="l">
               <a:lnSpc>
                 <a:spcPct val="120000"/>
               </a:lnSpc>
-              <a:spcAft>
-                <a:spcPts val="1600"/>
-              </a:spcAft>
-            </a:pPr>
-            <a:r>
-              <a:rPr sz="1300" b="1">
+            </a:pPr>
+            <a:r>
+              <a:rPr sz="1300" b="1" i="0">
                 <a:solidFill>
                   <a:srgbClr val="7A5A1E"/>
                 </a:solidFill>
@@ -9401,17 +9495,37 @@
               <a:t>Age 35–45, Middle Class households</a:t>
             </a:r>
           </a:p>
-          <a:p>
-            <a:pPr>
+        </p:txBody>
+      </p:sp>
+      <p:sp>
+        <p:nvSpPr>
+          <p:cNvPr id="12" name="TextBox 11"/>
+          <p:cNvSpPr txBox="1"/>
+          <p:nvPr/>
+        </p:nvSpPr>
+        <p:spPr>
+          <a:xfrm>
+            <a:off x="4703978" y="4910328"/>
+            <a:ext cx="2783738" cy="841247"/>
+          </a:xfrm>
+          <a:prstGeom prst="rect">
+            <a:avLst/>
+          </a:prstGeom>
+          <a:noFill/>
+        </p:spPr>
+        <p:txBody>
+          <a:bodyPr wrap="square" anchor="t" lIns="0" rIns="0" tIns="0" bIns="0">
+            <a:spAutoFit/>
+          </a:bodyPr>
+          <a:lstStyle/>
+          <a:p>
+            <a:pPr algn="l">
               <a:lnSpc>
                 <a:spcPct val="140000"/>
               </a:lnSpc>
-              <a:spcAft>
-                <a:spcPts val="0"/>
-              </a:spcAft>
-            </a:pPr>
-            <a:r>
-              <a:rPr sz="1300" b="0">
+            </a:pPr>
+            <a:r>
+              <a:rPr sz="1300" b="0" i="0">
                 <a:solidFill>
                   <a:srgbClr val="4A5568"/>
                 </a:solidFill>
@@ -9424,7 +9538,7 @@
       </p:sp>
       <p:sp>
         <p:nvSpPr>
-          <p:cNvPr id="7" name="Rounded Rectangle 6"/>
+          <p:cNvPr id="13" name="Rounded Rectangle 12"/>
           <p:cNvSpPr/>
           <p:nvPr/>
         </p:nvSpPr>
@@ -9470,113 +9584,14 @@
       </p:sp>
       <p:sp>
         <p:nvSpPr>
-          <p:cNvPr id="8" name="TextBox 7"/>
+          <p:cNvPr id="14" name="TextBox 13"/>
           <p:cNvSpPr txBox="1"/>
           <p:nvPr/>
         </p:nvSpPr>
         <p:spPr>
           <a:xfrm>
             <a:off x="8310676" y="3502152"/>
-            <a:ext cx="2783738" cy="3081528"/>
-          </a:xfrm>
-          <a:prstGeom prst="rect">
-            <a:avLst/>
-          </a:prstGeom>
-          <a:noFill/>
-        </p:spPr>
-        <p:txBody>
-          <a:bodyPr wrap="square" lIns="0" rIns="0" tIns="0" bIns="0">
-            <a:spAutoFit/>
-          </a:bodyPr>
-          <a:lstStyle/>
-          <a:p>
-            <a:pPr>
-              <a:lnSpc>
-                <a:spcPct val="100000"/>
-              </a:lnSpc>
-              <a:spcAft>
-                <a:spcPts val="1000"/>
-              </a:spcAft>
-            </a:pPr>
-            <a:r>
-              <a:rPr sz="1100" b="1" spc="100">
-                <a:solidFill>
-                  <a:srgbClr val="D9A857"/>
-                </a:solidFill>
-                <a:latin typeface="IBM Plex Sans"/>
-              </a:rPr>
-              <a:t>03 — HIGH-MARGIN PREMIUM</a:t>
-            </a:r>
-          </a:p>
-          <a:p>
-            <a:pPr>
-              <a:lnSpc>
-                <a:spcPct val="115000"/>
-              </a:lnSpc>
-              <a:spcAft>
-                <a:spcPts val="800"/>
-              </a:spcAft>
-            </a:pPr>
-            <a:r>
-              <a:rPr sz="1700" b="1">
-                <a:solidFill>
-                  <a:srgbClr val="F8F6F1"/>
-                </a:solidFill>
-                <a:latin typeface="Source Serif 4"/>
-              </a:rPr>
-              <a:t>Mitron Privé Elite</a:t>
-            </a:r>
-          </a:p>
-          <a:p>
-            <a:pPr>
-              <a:lnSpc>
-                <a:spcPct val="120000"/>
-              </a:lnSpc>
-              <a:spcAft>
-                <a:spcPts val="1600"/>
-              </a:spcAft>
-            </a:pPr>
-            <a:r>
-              <a:rPr sz="1300" b="1">
-                <a:solidFill>
-                  <a:srgbClr val="D9A857"/>
-                </a:solidFill>
-                <a:latin typeface="IBM Plex Sans"/>
-              </a:rPr>
-              <a:t>Upper Class &amp; business owners</a:t>
-            </a:r>
-          </a:p>
-          <a:p>
-            <a:pPr>
-              <a:lnSpc>
-                <a:spcPct val="140000"/>
-              </a:lnSpc>
-              <a:spcAft>
-                <a:spcPts val="0"/>
-              </a:spcAft>
-            </a:pPr>
-            <a:r>
-              <a:rPr sz="1300" b="0">
-                <a:solidFill>
-                  <a:srgbClr val="B9C2D6"/>
-                </a:solidFill>
-                <a:latin typeface="IBM Plex Sans"/>
-              </a:rPr>
-              <a:t>2x points on travel, dining &amp; wellness, 1.5% forex markup, concierge &amp; golf access.</a:t>
-            </a:r>
-          </a:p>
-        </p:txBody>
-      </p:sp>
-      <p:sp>
-        <p:nvSpPr>
-          <p:cNvPr id="9" name="TextBox 8"/>
-          <p:cNvSpPr txBox="1"/>
-          <p:nvPr/>
-        </p:nvSpPr>
-        <p:spPr>
-          <a:xfrm>
-            <a:off x="822960" y="6419088"/>
-            <a:ext cx="8686800" cy="274320"/>
+            <a:ext cx="2783738" cy="237744"/>
           </a:xfrm>
           <a:prstGeom prst="rect">
             <a:avLst/>
@@ -9595,6 +9610,162 @@
               </a:lnSpc>
             </a:pPr>
             <a:r>
+              <a:rPr sz="1100" b="1" i="0" spc="100">
+                <a:solidFill>
+                  <a:srgbClr val="D9A857"/>
+                </a:solidFill>
+                <a:latin typeface="IBM Plex Sans"/>
+              </a:rPr>
+              <a:t>03 — HIGH-MARGIN PREMIUM</a:t>
+            </a:r>
+          </a:p>
+        </p:txBody>
+      </p:sp>
+      <p:sp>
+        <p:nvSpPr>
+          <p:cNvPr id="15" name="TextBox 14"/>
+          <p:cNvSpPr txBox="1"/>
+          <p:nvPr/>
+        </p:nvSpPr>
+        <p:spPr>
+          <a:xfrm>
+            <a:off x="8310676" y="3776472"/>
+            <a:ext cx="2783738" cy="585216"/>
+          </a:xfrm>
+          <a:prstGeom prst="rect">
+            <a:avLst/>
+          </a:prstGeom>
+          <a:noFill/>
+        </p:spPr>
+        <p:txBody>
+          <a:bodyPr wrap="square" anchor="t" lIns="0" rIns="0" tIns="0" bIns="0">
+            <a:spAutoFit/>
+          </a:bodyPr>
+          <a:lstStyle/>
+          <a:p>
+            <a:pPr algn="l">
+              <a:lnSpc>
+                <a:spcPct val="115000"/>
+              </a:lnSpc>
+            </a:pPr>
+            <a:r>
+              <a:rPr sz="1700" b="1" i="0">
+                <a:solidFill>
+                  <a:srgbClr val="F8F6F1"/>
+                </a:solidFill>
+                <a:latin typeface="Source Serif 4"/>
+              </a:rPr>
+              <a:t>Mitron Privé Elite</a:t>
+            </a:r>
+          </a:p>
+        </p:txBody>
+      </p:sp>
+      <p:sp>
+        <p:nvSpPr>
+          <p:cNvPr id="16" name="TextBox 15"/>
+          <p:cNvSpPr txBox="1"/>
+          <p:nvPr/>
+        </p:nvSpPr>
+        <p:spPr>
+          <a:xfrm>
+            <a:off x="8310676" y="4489704"/>
+            <a:ext cx="2783738" cy="274320"/>
+          </a:xfrm>
+          <a:prstGeom prst="rect">
+            <a:avLst/>
+          </a:prstGeom>
+          <a:noFill/>
+        </p:spPr>
+        <p:txBody>
+          <a:bodyPr wrap="square" anchor="t" lIns="0" rIns="0" tIns="0" bIns="0">
+            <a:spAutoFit/>
+          </a:bodyPr>
+          <a:lstStyle/>
+          <a:p>
+            <a:pPr algn="l">
+              <a:lnSpc>
+                <a:spcPct val="120000"/>
+              </a:lnSpc>
+            </a:pPr>
+            <a:r>
+              <a:rPr sz="1300" b="1" i="0">
+                <a:solidFill>
+                  <a:srgbClr val="D9A857"/>
+                </a:solidFill>
+                <a:latin typeface="IBM Plex Sans"/>
+              </a:rPr>
+              <a:t>Upper Class &amp; business owners</a:t>
+            </a:r>
+          </a:p>
+        </p:txBody>
+      </p:sp>
+      <p:sp>
+        <p:nvSpPr>
+          <p:cNvPr id="17" name="TextBox 16"/>
+          <p:cNvSpPr txBox="1"/>
+          <p:nvPr/>
+        </p:nvSpPr>
+        <p:spPr>
+          <a:xfrm>
+            <a:off x="8310676" y="4910328"/>
+            <a:ext cx="2783738" cy="841247"/>
+          </a:xfrm>
+          <a:prstGeom prst="rect">
+            <a:avLst/>
+          </a:prstGeom>
+          <a:noFill/>
+        </p:spPr>
+        <p:txBody>
+          <a:bodyPr wrap="square" anchor="t" lIns="0" rIns="0" tIns="0" bIns="0">
+            <a:spAutoFit/>
+          </a:bodyPr>
+          <a:lstStyle/>
+          <a:p>
+            <a:pPr algn="l">
+              <a:lnSpc>
+                <a:spcPct val="140000"/>
+              </a:lnSpc>
+            </a:pPr>
+            <a:r>
+              <a:rPr sz="1300" b="0" i="0">
+                <a:solidFill>
+                  <a:srgbClr val="B9C2D6"/>
+                </a:solidFill>
+                <a:latin typeface="IBM Plex Sans"/>
+              </a:rPr>
+              <a:t>2x points on travel, dining &amp; wellness, 1.5% forex markup, concierge &amp; golf access.</a:t>
+            </a:r>
+          </a:p>
+        </p:txBody>
+      </p:sp>
+      <p:sp>
+        <p:nvSpPr>
+          <p:cNvPr id="18" name="TextBox 17"/>
+          <p:cNvSpPr txBox="1"/>
+          <p:nvPr/>
+        </p:nvSpPr>
+        <p:spPr>
+          <a:xfrm>
+            <a:off x="822960" y="6419088"/>
+            <a:ext cx="8686800" cy="274320"/>
+          </a:xfrm>
+          <a:prstGeom prst="rect">
+            <a:avLst/>
+          </a:prstGeom>
+          <a:noFill/>
+        </p:spPr>
+        <p:txBody>
+          <a:bodyPr wrap="square" anchor="t" lIns="0" rIns="0" tIns="0" bIns="0">
+            <a:spAutoFit/>
+          </a:bodyPr>
+          <a:lstStyle/>
+          <a:p>
+            <a:pPr algn="l">
+              <a:lnSpc>
+                <a:spcPct val="115000"/>
+              </a:lnSpc>
+            </a:pPr>
+            <a:r>
               <a:rPr sz="1100" b="0" i="0">
                 <a:solidFill>
                   <a:srgbClr val="6A7179"/>
@@ -9608,7 +9779,7 @@
       </p:sp>
       <p:sp>
         <p:nvSpPr>
-          <p:cNvPr id="10" name="TextBox 9"/>
+          <p:cNvPr id="19" name="TextBox 18"/>
           <p:cNvSpPr txBox="1"/>
           <p:nvPr/>
         </p:nvSpPr>
@@ -9742,7 +9913,7 @@
         </p:nvGraphicFramePr>
         <p:xfrm>
           <a:off x="822960" y="3246120"/>
-          <a:ext cx="10545774" cy="3291839"/>
+          <a:ext cx="10545774" cy="2651760"/>
         </p:xfrm>
         <a:graphic>
           <a:graphicData uri="http://schemas.openxmlformats.org/drawingml/2006/table">
@@ -9756,7 +9927,7 @@
                 <a:gridCol w="2847359"/>
                 <a:gridCol w="2847359"/>
               </a:tblGrid>
-              <a:tr h="658367">
+              <a:tr h="530352">
                 <a:tc>
                   <a:txBody>
                     <a:bodyPr wrap="square"/>
@@ -9846,7 +10017,7 @@
                   </a:tcPr>
                 </a:tc>
               </a:tr>
-              <a:tr h="658367">
+              <a:tr h="530352">
                 <a:tc>
                   <a:txBody>
                     <a:bodyPr wrap="square"/>
@@ -9936,7 +10107,7 @@
                   </a:tcPr>
                 </a:tc>
               </a:tr>
-              <a:tr h="658367">
+              <a:tr h="530352">
                 <a:tc>
                   <a:txBody>
                     <a:bodyPr wrap="square"/>
@@ -10026,7 +10197,7 @@
                   </a:tcPr>
                 </a:tc>
               </a:tr>
-              <a:tr h="658367">
+              <a:tr h="530352">
                 <a:tc>
                   <a:txBody>
                     <a:bodyPr wrap="square"/>
@@ -10116,7 +10287,7 @@
                   </a:tcPr>
                 </a:tc>
               </a:tr>
-              <a:tr h="658371">
+              <a:tr h="530352">
                 <a:tc>
                   <a:txBody>
                     <a:bodyPr wrap="square"/>

</xml_diff>